<commit_message>
correction du code du formulaire
</commit_message>
<xml_diff>
--- a/Fichier_Presentation DiabPredict.pptx
+++ b/Fichier_Presentation DiabPredict.pptx
@@ -114,6 +114,11 @@
       </a:defRPr>
     </a:lvl9pPr>
   </p:defaultTextStyle>
+  <p:extLst>
+    <p:ext uri="{EFAFB233-063F-42B5-8137-9DF3F51BA10A}">
+      <p15:sldGuideLst xmlns:p15="http://schemas.microsoft.com/office/powerpoint/2012/main"/>
+    </p:ext>
+  </p:extLst>
 </p:presentation>
 </file>
 
@@ -6014,13 +6019,13 @@
             <a:spLocks noGrp="1"/>
           </p:cNvSpPr>
           <p:nvPr>
-            <p:ph type="ctrTitle"/>
+            <p:ph type="title"/>
           </p:nvPr>
         </p:nvSpPr>
         <p:spPr>
           <a:xfrm>
-            <a:off x="490194" y="1447800"/>
-            <a:ext cx="9490419" cy="3859491"/>
+            <a:off x="0" y="1"/>
+            <a:ext cx="10435471" cy="1074656"/>
           </a:xfrm>
         </p:spPr>
         <p:txBody>
@@ -6028,220 +6033,65 @@
           <a:lstStyle/>
           <a:p>
             <a:r>
-              <a:rPr lang="fr-FR" sz="2000" b="1" dirty="0" smtClean="0">
+              <a:rPr lang="en-US" sz="2400" b="1" dirty="0" smtClean="0"/>
+              <a:t>        </a:t>
+            </a:r>
+            <a:r>
+              <a:rPr lang="en-US" sz="2400" b="1" dirty="0" smtClean="0">
                 <a:solidFill>
-                  <a:schemeClr val="tx1"/>
+                  <a:schemeClr val="accent3"/>
+                </a:solidFill>
+              </a:rPr>
+              <a:t>PRESENTATION DEL’APPLICATION DE PREDICTION DE DIABETE</a:t>
+            </a:r>
+            <a:br>
+              <a:rPr lang="en-US" sz="2400" b="1" dirty="0" smtClean="0">
+                <a:solidFill>
+                  <a:schemeClr val="accent3"/>
+                </a:solidFill>
+              </a:rPr>
+            </a:br>
+            <a:r>
+              <a:rPr lang="en-US" sz="2400" b="1" dirty="0" smtClean="0">
+                <a:solidFill>
+                  <a:schemeClr val="accent3"/>
+                </a:solidFill>
+              </a:rPr>
+              <a:t>                                         </a:t>
+            </a:r>
+            <a:r>
+              <a:rPr lang="fr-FR" sz="2400" b="1" dirty="0" smtClean="0">
+                <a:solidFill>
+                  <a:schemeClr val="accent3"/>
                 </a:solidFill>
               </a:rPr>
               <a:t>DiabPredict</a:t>
             </a:r>
             <a:r>
-              <a:rPr lang="fr-FR" sz="2000" b="1" dirty="0">
-                <a:solidFill>
-                  <a:schemeClr val="tx1"/>
-                </a:solidFill>
-              </a:rPr>
+              <a:rPr lang="fr-FR" sz="2800" dirty="0"/>
               <a:t/>
             </a:r>
             <a:br>
-              <a:rPr lang="fr-FR" sz="2000" b="1" dirty="0">
-                <a:solidFill>
-                  <a:schemeClr val="tx1"/>
-                </a:solidFill>
-              </a:rPr>
+              <a:rPr lang="fr-FR" sz="2800" dirty="0"/>
             </a:br>
-            <a:r>
-              <a:rPr lang="fr-FR" sz="2000" b="1" dirty="0">
-                <a:solidFill>
-                  <a:schemeClr val="tx1"/>
-                </a:solidFill>
-              </a:rPr>
-              <a:t>Prédiction du Diabète par Intelligence </a:t>
-            </a:r>
-            <a:r>
-              <a:rPr lang="fr-FR" sz="2000" b="1" dirty="0" smtClean="0">
-                <a:solidFill>
-                  <a:schemeClr val="tx1"/>
-                </a:solidFill>
-              </a:rPr>
-              <a:t>Artificielle</a:t>
-            </a:r>
-            <a:br>
-              <a:rPr lang="fr-FR" sz="2000" b="1" dirty="0" smtClean="0">
-                <a:solidFill>
-                  <a:schemeClr val="tx1"/>
-                </a:solidFill>
-              </a:rPr>
-            </a:br>
-            <a:r>
-              <a:rPr lang="fr-FR" sz="2000" b="1" dirty="0" smtClean="0">
-                <a:solidFill>
-                  <a:schemeClr val="tx1"/>
-                </a:solidFill>
-              </a:rPr>
-              <a:t>Cas des femmes</a:t>
-            </a:r>
-            <a:r>
-              <a:rPr lang="fr-FR" sz="2000" b="1" dirty="0">
-                <a:solidFill>
-                  <a:schemeClr val="tx1"/>
-                </a:solidFill>
-              </a:rPr>
-              <a:t/>
-            </a:r>
-            <a:br>
-              <a:rPr lang="fr-FR" sz="2000" b="1" dirty="0">
-                <a:solidFill>
-                  <a:schemeClr val="tx1"/>
-                </a:solidFill>
-              </a:rPr>
-            </a:br>
-            <a:r>
-              <a:rPr lang="fr-FR" sz="2000" b="1" dirty="0">
-                <a:solidFill>
-                  <a:schemeClr val="tx1"/>
-                </a:solidFill>
-              </a:rPr>
-              <a:t>Projet de Machine Learning</a:t>
-            </a:r>
-            <a:br>
-              <a:rPr lang="fr-FR" sz="2000" b="1" dirty="0">
-                <a:solidFill>
-                  <a:schemeClr val="tx1"/>
-                </a:solidFill>
-              </a:rPr>
-            </a:br>
-            <a:r>
-              <a:rPr lang="fr-FR" sz="2000" b="1" dirty="0">
-                <a:solidFill>
-                  <a:schemeClr val="tx1"/>
-                </a:solidFill>
-              </a:rPr>
-              <a:t>Domaine : Santé</a:t>
-            </a:r>
-            <a:br>
-              <a:rPr lang="fr-FR" sz="2000" b="1" dirty="0">
-                <a:solidFill>
-                  <a:schemeClr val="tx1"/>
-                </a:solidFill>
-              </a:rPr>
-            </a:br>
-            <a:r>
-              <a:rPr lang="fr-FR" sz="2000" b="1" dirty="0">
-                <a:solidFill>
-                  <a:schemeClr val="tx1"/>
-                </a:solidFill>
-              </a:rPr>
-              <a:t/>
-            </a:r>
-            <a:br>
-              <a:rPr lang="fr-FR" sz="2000" b="1" dirty="0">
-                <a:solidFill>
-                  <a:schemeClr val="tx1"/>
-                </a:solidFill>
-              </a:rPr>
-            </a:br>
-            <a:r>
-              <a:rPr lang="fr-FR" sz="2000" b="1" dirty="0">
-                <a:solidFill>
-                  <a:schemeClr val="tx1"/>
-                </a:solidFill>
-              </a:rPr>
-              <a:t>Réalisé par :</a:t>
-            </a:r>
-            <a:br>
-              <a:rPr lang="fr-FR" sz="2000" b="1" dirty="0">
-                <a:solidFill>
-                  <a:schemeClr val="tx1"/>
-                </a:solidFill>
-              </a:rPr>
-            </a:br>
-            <a:r>
-              <a:rPr lang="fr-FR" sz="2000" b="1" dirty="0" smtClean="0">
-                <a:solidFill>
-                  <a:schemeClr val="tx1"/>
-                </a:solidFill>
-              </a:rPr>
-              <a:t>- MUSHOBOZI </a:t>
-            </a:r>
-            <a:r>
-              <a:rPr lang="fr-FR" sz="2000" b="1" dirty="0">
-                <a:solidFill>
-                  <a:schemeClr val="tx1"/>
-                </a:solidFill>
-              </a:rPr>
-              <a:t>MUNGOBIJIRA Affable</a:t>
-            </a:r>
-            <a:br>
-              <a:rPr lang="fr-FR" sz="2000" b="1" dirty="0">
-                <a:solidFill>
-                  <a:schemeClr val="tx1"/>
-                </a:solidFill>
-              </a:rPr>
-            </a:br>
-            <a:r>
-              <a:rPr lang="fr-FR" sz="2000" b="1" dirty="0" smtClean="0">
-                <a:solidFill>
-                  <a:schemeClr val="tx1"/>
-                </a:solidFill>
-              </a:rPr>
-              <a:t>-  </a:t>
-            </a:r>
-            <a:r>
-              <a:rPr lang="fr-FR" sz="2000" b="1" dirty="0">
-                <a:solidFill>
-                  <a:schemeClr val="tx1"/>
-                </a:solidFill>
-              </a:rPr>
-              <a:t>Amani Sukuwabo Bravo</a:t>
-            </a:r>
-            <a:br>
-              <a:rPr lang="fr-FR" sz="2000" b="1" dirty="0">
-                <a:solidFill>
-                  <a:schemeClr val="tx1"/>
-                </a:solidFill>
-              </a:rPr>
-            </a:br>
-            <a:r>
-              <a:rPr lang="fr-FR" sz="2000" b="1" dirty="0">
-                <a:solidFill>
-                  <a:schemeClr val="tx1"/>
-                </a:solidFill>
-              </a:rPr>
-              <a:t/>
-            </a:r>
-            <a:br>
-              <a:rPr lang="fr-FR" sz="2000" b="1" dirty="0">
-                <a:solidFill>
-                  <a:schemeClr val="tx1"/>
-                </a:solidFill>
-              </a:rPr>
-            </a:br>
-            <a:r>
-              <a:rPr lang="fr-FR" sz="2000" b="1" dirty="0">
-                <a:solidFill>
-                  <a:schemeClr val="tx1"/>
-                </a:solidFill>
-              </a:rPr>
-              <a:t>Date : Juillet 2026</a:t>
-            </a:r>
-          </a:p>
-        </p:txBody>
-      </p:sp>
-      <p:sp>
-        <p:nvSpPr>
-          <p:cNvPr id="3" name="Sous-titre 2"/>
-          <p:cNvSpPr>
-            <a:spLocks noGrp="1"/>
-          </p:cNvSpPr>
-          <p:nvPr>
-            <p:ph type="subTitle" idx="1"/>
+            <a:endParaRPr lang="fr-FR" sz="2800" dirty="0"/>
+          </a:p>
+        </p:txBody>
+      </p:sp>
+      <p:sp>
+        <p:nvSpPr>
+          <p:cNvPr id="7" name="Espace réservé du contenu 6"/>
+          <p:cNvSpPr>
+            <a:spLocks noGrp="1"/>
+          </p:cNvSpPr>
+          <p:nvPr>
+            <p:ph idx="1"/>
           </p:nvPr>
         </p:nvSpPr>
         <p:spPr>
           <a:xfrm>
-            <a:off x="1154955" y="5307290"/>
-            <a:ext cx="8825658" cy="791852"/>
+            <a:off x="254524" y="697584"/>
+            <a:ext cx="9795330" cy="5550815"/>
           </a:xfrm>
         </p:spPr>
         <p:txBody>
@@ -6250,27 +6100,136 @@
           </a:bodyPr>
           <a:lstStyle/>
           <a:p>
-            <a:r>
-              <a:rPr lang="en-US" b="1" dirty="0" smtClean="0">
-                <a:solidFill>
-                  <a:schemeClr val="accent3"/>
-                </a:solidFill>
-              </a:rPr>
-              <a:t>Presentation de l’application de prediction de </a:t>
-            </a:r>
-            <a:r>
-              <a:rPr lang="en-US" b="1" dirty="0" err="1" smtClean="0">
-                <a:solidFill>
-                  <a:schemeClr val="accent3"/>
-                </a:solidFill>
-              </a:rPr>
-              <a:t>diabete</a:t>
-            </a:r>
-            <a:endParaRPr lang="fr-FR" b="1" dirty="0">
-              <a:solidFill>
-                <a:schemeClr val="accent3"/>
-              </a:solidFill>
-            </a:endParaRPr>
+            <a:pPr marL="0" indent="0">
+              <a:buNone/>
+            </a:pPr>
+            <a:r>
+              <a:rPr lang="fr-FR" dirty="0" smtClean="0"/>
+              <a:t>              </a:t>
+            </a:r>
+          </a:p>
+          <a:p>
+            <a:pPr marL="0" indent="0">
+              <a:buNone/>
+            </a:pPr>
+            <a:r>
+              <a:rPr lang="fr-FR" dirty="0"/>
+              <a:t> </a:t>
+            </a:r>
+            <a:r>
+              <a:rPr lang="fr-FR" dirty="0" smtClean="0"/>
+              <a:t>             Prédiction </a:t>
+            </a:r>
+            <a:r>
+              <a:rPr lang="fr-FR" dirty="0"/>
+              <a:t>du Diabète par Intelligence </a:t>
+            </a:r>
+            <a:r>
+              <a:rPr lang="fr-FR" dirty="0" smtClean="0"/>
+              <a:t>Artificielle</a:t>
+            </a:r>
+          </a:p>
+          <a:p>
+            <a:pPr marL="0" indent="0">
+              <a:buNone/>
+            </a:pPr>
+            <a:r>
+              <a:rPr lang="en-US" dirty="0" smtClean="0"/>
+              <a:t>                     Cas des Femmes</a:t>
+            </a:r>
+            <a:endParaRPr lang="fr-FR" dirty="0"/>
+          </a:p>
+          <a:p>
+            <a:endParaRPr lang="fr-FR" dirty="0"/>
+          </a:p>
+          <a:p>
+            <a:pPr marL="0" indent="0">
+              <a:buNone/>
+            </a:pPr>
+            <a:r>
+              <a:rPr lang="fr-FR" dirty="0" smtClean="0"/>
+              <a:t>                  Projet </a:t>
+            </a:r>
+            <a:r>
+              <a:rPr lang="fr-FR" dirty="0"/>
+              <a:t>de Machine </a:t>
+            </a:r>
+            <a:r>
+              <a:rPr lang="fr-FR" dirty="0" smtClean="0"/>
+              <a:t>Learning</a:t>
+            </a:r>
+          </a:p>
+          <a:p>
+            <a:pPr marL="0" indent="0">
+              <a:buNone/>
+            </a:pPr>
+            <a:r>
+              <a:rPr lang="en-US" dirty="0"/>
+              <a:t> </a:t>
+            </a:r>
+            <a:r>
+              <a:rPr lang="en-US" dirty="0" smtClean="0"/>
+              <a:t>                Domaine :Santé</a:t>
+            </a:r>
+            <a:endParaRPr lang="fr-FR" dirty="0"/>
+          </a:p>
+          <a:p>
+            <a:endParaRPr lang="fr-FR" dirty="0"/>
+          </a:p>
+          <a:p>
+            <a:pPr marL="0" indent="0">
+              <a:buNone/>
+            </a:pPr>
+            <a:r>
+              <a:rPr lang="fr-FR" dirty="0" smtClean="0"/>
+              <a:t>                 Présenté </a:t>
+            </a:r>
+            <a:r>
+              <a:rPr lang="fr-FR" dirty="0"/>
+              <a:t>par :</a:t>
+            </a:r>
+          </a:p>
+          <a:p>
+            <a:pPr marL="0" indent="0">
+              <a:buNone/>
+            </a:pPr>
+            <a:r>
+              <a:rPr lang="fr-FR" dirty="0" smtClean="0"/>
+              <a:t>                       - </a:t>
+            </a:r>
+            <a:r>
+              <a:rPr lang="fr-FR" dirty="0"/>
+              <a:t>MUSHOBOZI MUNGOBIJIRA Affable</a:t>
+            </a:r>
+          </a:p>
+          <a:p>
+            <a:pPr marL="0" indent="0">
+              <a:buNone/>
+            </a:pPr>
+            <a:r>
+              <a:rPr lang="fr-FR" dirty="0" smtClean="0"/>
+              <a:t>                       - </a:t>
+            </a:r>
+            <a:r>
+              <a:rPr lang="fr-FR" dirty="0"/>
+              <a:t>Amani Sukuwabo Bravo</a:t>
+            </a:r>
+          </a:p>
+          <a:p>
+            <a:endParaRPr lang="fr-FR" dirty="0"/>
+          </a:p>
+          <a:p>
+            <a:pPr marL="0" indent="0">
+              <a:buNone/>
+            </a:pPr>
+            <a:r>
+              <a:rPr lang="fr-FR" dirty="0" smtClean="0"/>
+              <a:t>                    Date </a:t>
+            </a:r>
+            <a:r>
+              <a:rPr lang="fr-FR" dirty="0"/>
+              <a:t>: Juillet 2026</a:t>
+            </a:r>
           </a:p>
         </p:txBody>
       </p:sp>
@@ -6583,8 +6542,8 @@
         </p:nvSpPr>
         <p:spPr>
           <a:xfrm>
-            <a:off x="646111" y="452718"/>
-            <a:ext cx="9808215" cy="838754"/>
+            <a:off x="646111" y="-122548"/>
+            <a:ext cx="9808215" cy="631595"/>
           </a:xfrm>
         </p:spPr>
         <p:txBody>
@@ -6615,13 +6574,13 @@
         </p:nvSpPr>
         <p:spPr>
           <a:xfrm>
-            <a:off x="1103312" y="1385740"/>
-            <a:ext cx="8946541" cy="5099901"/>
+            <a:off x="1960775" y="509047"/>
+            <a:ext cx="7814821" cy="6348953"/>
           </a:xfrm>
         </p:spPr>
         <p:txBody>
           <a:bodyPr>
-            <a:normAutofit fontScale="40000" lnSpcReduction="20000"/>
+            <a:noAutofit/>
           </a:bodyPr>
           <a:lstStyle/>
           <a:p>
@@ -6629,8 +6588,16 @@
               <a:buNone/>
             </a:pPr>
             <a:r>
-              <a:rPr lang="fr-FR" dirty="0"/>
-              <a:t>Prédiction en temps réel</a:t>
+              <a:rPr lang="fr-FR" sz="1000" dirty="0" smtClean="0"/>
+              <a:t>                                                           </a:t>
+            </a:r>
+            <a:r>
+              <a:rPr lang="fr-FR" sz="1000" b="1" dirty="0" smtClean="0"/>
+              <a:t>Prédiction </a:t>
+            </a:r>
+            <a:r>
+              <a:rPr lang="fr-FR" sz="1000" b="1" dirty="0"/>
+              <a:t>en temps réel</a:t>
             </a:r>
           </a:p>
           <a:p>
@@ -6638,8 +6605,16 @@
               <a:buNone/>
             </a:pPr>
             <a:r>
-              <a:rPr lang="fr-FR" dirty="0"/>
-              <a:t>Saisie des 8 paramètres médicaux</a:t>
+              <a:rPr lang="fr-FR" sz="1000" dirty="0" smtClean="0"/>
+              <a:t>                                                    -Saisie </a:t>
+            </a:r>
+            <a:r>
+              <a:rPr lang="fr-FR" sz="1000" dirty="0"/>
+              <a:t>des 8 </a:t>
+            </a:r>
+            <a:r>
+              <a:rPr lang="fr-FR" sz="1000" dirty="0" smtClean="0"/>
+              <a:t>paramètres</a:t>
             </a:r>
           </a:p>
           <a:p>
@@ -6647,17 +6622,37 @@
               <a:buNone/>
             </a:pPr>
             <a:r>
-              <a:rPr lang="fr-FR" dirty="0"/>
-              <a:t>Résultat instantané avec probabilité</a:t>
-            </a:r>
-          </a:p>
-          <a:p>
-            <a:pPr marL="0" indent="0">
-              <a:buNone/>
-            </a:pPr>
-            <a:r>
-              <a:rPr lang="fr-FR" dirty="0"/>
-              <a:t>Base de données SQLite</a:t>
+              <a:rPr lang="fr-FR" sz="1000" dirty="0"/>
+              <a:t> </a:t>
+            </a:r>
+            <a:r>
+              <a:rPr lang="fr-FR" sz="1000" dirty="0" smtClean="0"/>
+              <a:t>                                                  </a:t>
+            </a:r>
+            <a:r>
+              <a:rPr lang="fr-FR" sz="1000" dirty="0" smtClean="0"/>
+              <a:t> -Résultat </a:t>
+            </a:r>
+            <a:r>
+              <a:rPr lang="fr-FR" sz="1000" dirty="0"/>
+              <a:t>instantané avec probabilité</a:t>
+            </a:r>
+          </a:p>
+          <a:p>
+            <a:pPr marL="0" indent="0">
+              <a:buNone/>
+            </a:pPr>
+            <a:r>
+              <a:rPr lang="fr-FR" sz="1000" dirty="0" smtClean="0"/>
+              <a:t>                                                                  </a:t>
+            </a:r>
+            <a:r>
+              <a:rPr lang="fr-FR" sz="1000" b="1" dirty="0" smtClean="0"/>
+              <a:t>Base </a:t>
+            </a:r>
+            <a:r>
+              <a:rPr lang="fr-FR" sz="1000" b="1" dirty="0"/>
+              <a:t>de données SQLite</a:t>
             </a:r>
           </a:p>
           <a:p>
@@ -6665,8 +6660,8 @@
               <a:buNone/>
             </a:pPr>
             <a:r>
-              <a:rPr lang="fr-FR" dirty="0"/>
-              <a:t>Sauvegarde des patients et prédictions</a:t>
+              <a:rPr lang="fr-FR" sz="1000" dirty="0" smtClean="0"/>
+              <a:t>                                                               Sauvegarde:</a:t>
             </a:r>
           </a:p>
           <a:p>
@@ -6674,8 +6669,24 @@
               <a:buNone/>
             </a:pPr>
             <a:r>
-              <a:rPr lang="fr-FR" dirty="0"/>
-              <a:t>Historique complet</a:t>
+              <a:rPr lang="fr-FR" sz="1000" dirty="0"/>
+              <a:t> </a:t>
+            </a:r>
+            <a:r>
+              <a:rPr lang="fr-FR" sz="1000" dirty="0" smtClean="0"/>
+              <a:t>                                                                -</a:t>
+            </a:r>
+            <a:r>
+              <a:rPr lang="fr-FR" sz="1000" dirty="0" smtClean="0"/>
+              <a:t> </a:t>
+            </a:r>
+            <a:r>
+              <a:rPr lang="fr-FR" sz="1000" dirty="0"/>
+              <a:t>des patients </a:t>
+            </a:r>
+            <a:r>
+              <a:rPr lang="fr-FR" sz="1000" dirty="0" smtClean="0"/>
+              <a:t>et</a:t>
             </a:r>
           </a:p>
           <a:p>
@@ -6683,17 +6694,20 @@
               <a:buNone/>
             </a:pPr>
             <a:r>
-              <a:rPr lang="fr-FR" dirty="0"/>
-              <a:t>Statistiques globales</a:t>
-            </a:r>
-          </a:p>
-          <a:p>
-            <a:pPr marL="0" indent="0">
-              <a:buNone/>
-            </a:pPr>
-            <a:r>
-              <a:rPr lang="fr-FR" dirty="0"/>
-              <a:t>CRUD complet</a:t>
+              <a:rPr lang="fr-FR" sz="1000" dirty="0"/>
+              <a:t> </a:t>
+            </a:r>
+            <a:r>
+              <a:rPr lang="fr-FR" sz="1000" dirty="0" smtClean="0"/>
+              <a:t>                                                                  -</a:t>
+            </a:r>
+            <a:r>
+              <a:rPr lang="fr-FR" sz="1000" dirty="0" smtClean="0"/>
+              <a:t> </a:t>
+            </a:r>
+            <a:r>
+              <a:rPr lang="fr-FR" sz="1000" dirty="0"/>
+              <a:t>prédictions</a:t>
             </a:r>
           </a:p>
           <a:p>
@@ -6701,26 +6715,61 @@
               <a:buNone/>
             </a:pPr>
             <a:r>
-              <a:rPr lang="fr-FR" dirty="0"/>
-              <a:t>Créer : Ajouter un patient</a:t>
-            </a:r>
+              <a:rPr lang="fr-FR" sz="1000" dirty="0" smtClean="0"/>
+              <a:t>                                                                   -Historique complet(global et détaillé).</a:t>
+            </a:r>
+            <a:endParaRPr lang="fr-FR" sz="1000" dirty="0"/>
           </a:p>
           <a:p>
             <a:pPr marL="457200" lvl="1" indent="0">
               <a:buNone/>
             </a:pPr>
             <a:r>
-              <a:rPr lang="fr-FR" dirty="0"/>
-              <a:t>Lire : Voir l'historique</a:t>
-            </a:r>
+              <a:rPr lang="fr-FR" sz="1000" dirty="0" smtClean="0"/>
+              <a:t>                                                                   -Statistiques </a:t>
+            </a:r>
+            <a:r>
+              <a:rPr lang="fr-FR" sz="1000" dirty="0"/>
+              <a:t>globales</a:t>
+            </a:r>
+          </a:p>
+          <a:p>
+            <a:pPr marL="0" indent="0">
+              <a:buNone/>
+            </a:pPr>
+            <a:r>
+              <a:rPr lang="fr-FR" sz="1000" dirty="0" smtClean="0"/>
+              <a:t>                                                               </a:t>
+            </a:r>
+            <a:r>
+              <a:rPr lang="fr-FR" sz="1000" b="1" dirty="0" smtClean="0"/>
+              <a:t>CRUD complet(</a:t>
+            </a:r>
+            <a:r>
+              <a:rPr lang="fr-FR" sz="1000" b="1" dirty="0" err="1" smtClean="0"/>
+              <a:t>create,Read</a:t>
+            </a:r>
+            <a:r>
+              <a:rPr lang="fr-FR" sz="1000" b="1" dirty="0" smtClean="0"/>
+              <a:t> ,update and delete)</a:t>
+            </a:r>
+            <a:endParaRPr lang="fr-FR" sz="1000" b="1" dirty="0"/>
           </a:p>
           <a:p>
             <a:pPr marL="457200" lvl="1" indent="0">
               <a:buNone/>
             </a:pPr>
             <a:r>
-              <a:rPr lang="fr-FR" dirty="0"/>
-              <a:t>Modifier : Corriger les données</a:t>
+              <a:rPr lang="fr-FR" sz="1000" dirty="0" smtClean="0"/>
+              <a:t>                                                           </a:t>
+            </a:r>
+            <a:r>
+              <a:rPr lang="fr-FR" sz="1000" b="1" dirty="0" smtClean="0"/>
+              <a:t>Créer </a:t>
+            </a:r>
+            <a:r>
+              <a:rPr lang="fr-FR" sz="1000" b="1" dirty="0"/>
+              <a:t>: Ajouter un patient</a:t>
             </a:r>
           </a:p>
           <a:p>
@@ -6728,17 +6777,12 @@
               <a:buNone/>
             </a:pPr>
             <a:r>
-              <a:rPr lang="fr-FR" dirty="0"/>
-              <a:t>Supprimer : Effacer une entrée</a:t>
-            </a:r>
-          </a:p>
-          <a:p>
-            <a:pPr marL="0" indent="0">
-              <a:buNone/>
-            </a:pPr>
-            <a:r>
-              <a:rPr lang="fr-FR" dirty="0"/>
-              <a:t>Rapports</a:t>
+              <a:rPr lang="fr-FR" sz="1000" dirty="0" smtClean="0"/>
+              <a:t>                                                          Lire </a:t>
+            </a:r>
+            <a:r>
+              <a:rPr lang="fr-FR" sz="1000" dirty="0"/>
+              <a:t>: Voir l'historique</a:t>
             </a:r>
           </a:p>
           <a:p>
@@ -6746,8 +6790,12 @@
               <a:buNone/>
             </a:pPr>
             <a:r>
-              <a:rPr lang="fr-FR" dirty="0"/>
-              <a:t>Rapport individuel par patient</a:t>
+              <a:rPr lang="fr-FR" sz="1000" dirty="0" smtClean="0"/>
+              <a:t>                                                         Modifier </a:t>
+            </a:r>
+            <a:r>
+              <a:rPr lang="fr-FR" sz="1000" dirty="0"/>
+              <a:t>: Corriger les données</a:t>
             </a:r>
           </a:p>
           <a:p>
@@ -6755,26 +6803,39 @@
               <a:buNone/>
             </a:pPr>
             <a:r>
-              <a:rPr lang="fr-FR" dirty="0"/>
-              <a:t>Rapport global (toutes les prédictions)</a:t>
-            </a:r>
+              <a:rPr lang="fr-FR" sz="1000" dirty="0" smtClean="0"/>
+              <a:t>                                                         Supprimer </a:t>
+            </a:r>
+            <a:r>
+              <a:rPr lang="fr-FR" sz="1000" dirty="0"/>
+              <a:t>: Effacer une entrée</a:t>
+            </a:r>
+          </a:p>
+          <a:p>
+            <a:pPr marL="0" indent="0">
+              <a:buNone/>
+            </a:pPr>
+            <a:r>
+              <a:rPr lang="fr-FR" sz="1000" dirty="0" smtClean="0"/>
+              <a:t>                                                                      </a:t>
+            </a:r>
+            <a:r>
+              <a:rPr lang="fr-FR" sz="1000" b="1" dirty="0" smtClean="0"/>
+              <a:t>Rapports:</a:t>
+            </a:r>
+            <a:endParaRPr lang="fr-FR" sz="1000" b="1" dirty="0"/>
           </a:p>
           <a:p>
             <a:pPr marL="457200" lvl="1" indent="0">
               <a:buNone/>
             </a:pPr>
             <a:r>
-              <a:rPr lang="fr-FR" dirty="0"/>
-              <a:t>Impression des rapports</a:t>
-            </a:r>
-          </a:p>
-          <a:p>
-            <a:pPr marL="0" indent="0">
-              <a:buNone/>
-            </a:pPr>
-            <a:r>
-              <a:rPr lang="fr-FR" dirty="0"/>
-              <a:t>Interface professionnelle</a:t>
+              <a:rPr lang="fr-FR" sz="1000" dirty="0" smtClean="0"/>
+              <a:t>                                                               -Rapport </a:t>
+            </a:r>
+            <a:r>
+              <a:rPr lang="fr-FR" sz="1000" dirty="0"/>
+              <a:t>individuel par patient</a:t>
             </a:r>
           </a:p>
           <a:p>
@@ -6782,8 +6843,12 @@
               <a:buNone/>
             </a:pPr>
             <a:r>
-              <a:rPr lang="fr-FR" dirty="0"/>
-              <a:t>Navigation intuitive</a:t>
+              <a:rPr lang="fr-FR" sz="1000" dirty="0" smtClean="0"/>
+              <a:t>                                                              -Rapport </a:t>
+            </a:r>
+            <a:r>
+              <a:rPr lang="fr-FR" sz="1000" dirty="0"/>
+              <a:t>global (toutes les prédictions)</a:t>
             </a:r>
           </a:p>
           <a:p>
@@ -6791,8 +6856,25 @@
               <a:buNone/>
             </a:pPr>
             <a:r>
-              <a:rPr lang="fr-FR" dirty="0"/>
-              <a:t>Design responsive</a:t>
+              <a:rPr lang="fr-FR" sz="1000" dirty="0" smtClean="0"/>
+              <a:t>                                                              -Impression </a:t>
+            </a:r>
+            <a:r>
+              <a:rPr lang="fr-FR" sz="1000" dirty="0"/>
+              <a:t>des rapports</a:t>
+            </a:r>
+          </a:p>
+          <a:p>
+            <a:pPr marL="0" indent="0">
+              <a:buNone/>
+            </a:pPr>
+            <a:r>
+              <a:rPr lang="fr-FR" sz="1000" b="1" dirty="0" smtClean="0"/>
+              <a:t>                                                                    Interface </a:t>
+            </a:r>
+            <a:r>
+              <a:rPr lang="fr-FR" sz="1000" b="1" dirty="0"/>
+              <a:t>professionnelle</a:t>
             </a:r>
           </a:p>
           <a:p>
@@ -6800,22 +6882,52 @@
               <a:buNone/>
             </a:pPr>
             <a:r>
-              <a:rPr lang="fr-FR" dirty="0"/>
-              <a:t>Visualisation des statistiques</a:t>
-            </a:r>
-          </a:p>
-          <a:p>
-            <a:pPr marL="0" indent="0">
-              <a:buNone/>
-            </a:pPr>
-            <a:r>
-              <a:rPr lang="fr-FR" dirty="0"/>
+              <a:rPr lang="fr-FR" sz="1000" dirty="0" smtClean="0"/>
+              <a:t>                                                                -Navigation </a:t>
+            </a:r>
+            <a:r>
+              <a:rPr lang="fr-FR" sz="1000" dirty="0"/>
+              <a:t>intuitive</a:t>
+            </a:r>
+          </a:p>
+          <a:p>
+            <a:pPr marL="457200" lvl="1" indent="0">
+              <a:buNone/>
+            </a:pPr>
+            <a:r>
+              <a:rPr lang="fr-FR" sz="1000" dirty="0" smtClean="0"/>
+              <a:t>                                                                 -Design </a:t>
+            </a:r>
+            <a:r>
+              <a:rPr lang="fr-FR" sz="1000" dirty="0"/>
+              <a:t>responsive</a:t>
+            </a:r>
+          </a:p>
+          <a:p>
+            <a:pPr marL="457200" lvl="1" indent="0">
+              <a:buNone/>
+            </a:pPr>
+            <a:r>
+              <a:rPr lang="fr-FR" sz="1000" dirty="0" smtClean="0"/>
+              <a:t>                                                                -Visualisation </a:t>
+            </a:r>
+            <a:r>
+              <a:rPr lang="fr-FR" sz="1000" dirty="0"/>
+              <a:t>des statistiques</a:t>
+            </a:r>
+          </a:p>
+          <a:p>
+            <a:pPr marL="0" indent="0">
+              <a:buNone/>
+            </a:pPr>
+            <a:r>
+              <a:rPr lang="fr-FR" sz="1000" dirty="0"/>
               <a:t/>
             </a:r>
             <a:br>
-              <a:rPr lang="fr-FR" dirty="0"/>
+              <a:rPr lang="fr-FR" sz="1000" dirty="0"/>
             </a:br>
-            <a:endParaRPr lang="fr-FR" dirty="0"/>
+            <a:endParaRPr lang="fr-FR" sz="1000" dirty="0"/>
           </a:p>
         </p:txBody>
       </p:sp>
@@ -6851,18 +6963,18 @@
       </p:grpSpPr>
       <p:sp>
         <p:nvSpPr>
-          <p:cNvPr id="2" name="Titre 1"/>
-          <p:cNvSpPr>
-            <a:spLocks noGrp="1"/>
-          </p:cNvSpPr>
-          <p:nvPr>
-            <p:ph type="ctrTitle"/>
+          <p:cNvPr id="4" name="Titre 3"/>
+          <p:cNvSpPr>
+            <a:spLocks noGrp="1"/>
+          </p:cNvSpPr>
+          <p:nvPr>
+            <p:ph type="title"/>
           </p:nvPr>
         </p:nvSpPr>
         <p:spPr>
           <a:xfrm>
-            <a:off x="603315" y="527901"/>
-            <a:ext cx="9078013" cy="4402318"/>
+            <a:off x="1866506" y="122548"/>
+            <a:ext cx="7522591" cy="895547"/>
           </a:xfrm>
         </p:spPr>
         <p:txBody>
@@ -6870,226 +6982,28 @@
           <a:lstStyle/>
           <a:p>
             <a:r>
-              <a:rPr lang="fr-FR" sz="1800" b="1" dirty="0">
+              <a:rPr lang="fr-FR" b="1" dirty="0" smtClean="0"/>
+              <a:t>       </a:t>
+            </a:r>
+            <a:r>
+              <a:rPr lang="fr-FR" b="1" dirty="0" smtClean="0">
                 <a:solidFill>
-                  <a:schemeClr val="tx1"/>
+                  <a:schemeClr val="accent3"/>
                 </a:solidFill>
               </a:rPr>
-              <a:t/>
-            </a:r>
-            <a:br>
-              <a:rPr lang="fr-FR" sz="1800" b="1" dirty="0">
+              <a:t>Plan </a:t>
+            </a:r>
+            <a:r>
+              <a:rPr lang="fr-FR" b="1" dirty="0">
                 <a:solidFill>
-                  <a:schemeClr val="tx1"/>
+                  <a:schemeClr val="accent3"/>
                 </a:solidFill>
               </a:rPr>
-            </a:br>
-            <a:r>
-              <a:rPr lang="fr-FR" sz="1800" b="1" dirty="0">
-                <a:solidFill>
-                  <a:schemeClr val="tx1"/>
-                </a:solidFill>
-              </a:rPr>
-              <a:t/>
-            </a:r>
-            <a:br>
-              <a:rPr lang="fr-FR" sz="1800" b="1" dirty="0">
-                <a:solidFill>
-                  <a:schemeClr val="tx1"/>
-                </a:solidFill>
-              </a:rPr>
-            </a:br>
-            <a:r>
-              <a:rPr lang="fr-FR" sz="1800" b="1" dirty="0">
-                <a:solidFill>
-                  <a:schemeClr val="tx1"/>
-                </a:solidFill>
-              </a:rPr>
-              <a:t>1. Introduction et Problématique</a:t>
-            </a:r>
-            <a:br>
-              <a:rPr lang="fr-FR" sz="1800" b="1" dirty="0">
-                <a:solidFill>
-                  <a:schemeClr val="tx1"/>
-                </a:solidFill>
-              </a:rPr>
-            </a:br>
-            <a:r>
-              <a:rPr lang="fr-FR" sz="1800" b="1" dirty="0">
-                <a:solidFill>
-                  <a:schemeClr val="tx1"/>
-                </a:solidFill>
-              </a:rPr>
-              <a:t>2. Objectifs du projet</a:t>
-            </a:r>
-            <a:br>
-              <a:rPr lang="fr-FR" sz="1800" b="1" dirty="0">
-                <a:solidFill>
-                  <a:schemeClr val="tx1"/>
-                </a:solidFill>
-              </a:rPr>
-            </a:br>
-            <a:r>
-              <a:rPr lang="fr-FR" sz="1800" b="1" dirty="0">
-                <a:solidFill>
-                  <a:schemeClr val="tx1"/>
-                </a:solidFill>
-              </a:rPr>
-              <a:t>3. Le Dataset (Pima Indians Diabetes)</a:t>
-            </a:r>
-            <a:br>
-              <a:rPr lang="fr-FR" sz="1800" b="1" dirty="0">
-                <a:solidFill>
-                  <a:schemeClr val="tx1"/>
-                </a:solidFill>
-              </a:rPr>
-            </a:br>
-            <a:r>
-              <a:rPr lang="fr-FR" sz="1800" b="1" dirty="0">
-                <a:solidFill>
-                  <a:schemeClr val="tx1"/>
-                </a:solidFill>
-              </a:rPr>
-              <a:t>4. Analyse Exploratoire des Données</a:t>
-            </a:r>
-            <a:br>
-              <a:rPr lang="fr-FR" sz="1800" b="1" dirty="0">
-                <a:solidFill>
-                  <a:schemeClr val="tx1"/>
-                </a:solidFill>
-              </a:rPr>
-            </a:br>
-            <a:r>
-              <a:rPr lang="fr-FR" sz="1800" b="1" dirty="0">
-                <a:solidFill>
-                  <a:schemeClr val="tx1"/>
-                </a:solidFill>
-              </a:rPr>
-              <a:t>5. Préparation des Données</a:t>
-            </a:r>
-            <a:br>
-              <a:rPr lang="fr-FR" sz="1800" b="1" dirty="0">
-                <a:solidFill>
-                  <a:schemeClr val="tx1"/>
-                </a:solidFill>
-              </a:rPr>
-            </a:br>
-            <a:r>
-              <a:rPr lang="fr-FR" sz="1800" b="1" dirty="0">
-                <a:solidFill>
-                  <a:schemeClr val="tx1"/>
-                </a:solidFill>
-              </a:rPr>
-              <a:t>6. Modèles de Machine Learning utilisés</a:t>
-            </a:r>
-            <a:br>
-              <a:rPr lang="fr-FR" sz="1800" b="1" dirty="0">
-                <a:solidFill>
-                  <a:schemeClr val="tx1"/>
-                </a:solidFill>
-              </a:rPr>
-            </a:br>
-            <a:r>
-              <a:rPr lang="fr-FR" sz="1800" b="1" dirty="0">
-                <a:solidFill>
-                  <a:schemeClr val="tx1"/>
-                </a:solidFill>
-              </a:rPr>
-              <a:t>7. Évaluation et Comparaison</a:t>
-            </a:r>
-            <a:br>
-              <a:rPr lang="fr-FR" sz="1800" b="1" dirty="0">
-                <a:solidFill>
-                  <a:schemeClr val="tx1"/>
-                </a:solidFill>
-              </a:rPr>
-            </a:br>
-            <a:r>
-              <a:rPr lang="fr-FR" sz="1800" b="1" dirty="0">
-                <a:solidFill>
-                  <a:schemeClr val="tx1"/>
-                </a:solidFill>
-              </a:rPr>
-              <a:t>8. Déploiement de l'Application</a:t>
-            </a:r>
-            <a:br>
-              <a:rPr lang="fr-FR" sz="1800" b="1" dirty="0">
-                <a:solidFill>
-                  <a:schemeClr val="tx1"/>
-                </a:solidFill>
-              </a:rPr>
-            </a:br>
-            <a:r>
-              <a:rPr lang="fr-FR" sz="1800" b="1" dirty="0">
-                <a:solidFill>
-                  <a:schemeClr val="tx1"/>
-                </a:solidFill>
-              </a:rPr>
-              <a:t>9. Architecture de l'Application</a:t>
-            </a:r>
-            <a:br>
-              <a:rPr lang="fr-FR" sz="1800" b="1" dirty="0">
-                <a:solidFill>
-                  <a:schemeClr val="tx1"/>
-                </a:solidFill>
-              </a:rPr>
-            </a:br>
-            <a:r>
-              <a:rPr lang="fr-FR" sz="1800" b="1" dirty="0">
-                <a:solidFill>
-                  <a:schemeClr val="tx1"/>
-                </a:solidFill>
-              </a:rPr>
-              <a:t>10. Fonctionnalités</a:t>
-            </a:r>
-            <a:br>
-              <a:rPr lang="fr-FR" sz="1800" b="1" dirty="0">
-                <a:solidFill>
-                  <a:schemeClr val="tx1"/>
-                </a:solidFill>
-              </a:rPr>
-            </a:br>
-            <a:r>
-              <a:rPr lang="fr-FR" sz="1800" b="1" dirty="0">
-                <a:solidFill>
-                  <a:schemeClr val="tx1"/>
-                </a:solidFill>
-              </a:rPr>
-              <a:t>11. Démonstration</a:t>
-            </a:r>
-            <a:br>
-              <a:rPr lang="fr-FR" sz="1800" b="1" dirty="0">
-                <a:solidFill>
-                  <a:schemeClr val="tx1"/>
-                </a:solidFill>
-              </a:rPr>
-            </a:br>
-            <a:r>
-              <a:rPr lang="fr-FR" sz="1800" b="1" dirty="0">
-                <a:solidFill>
-                  <a:schemeClr val="tx1"/>
-                </a:solidFill>
-              </a:rPr>
-              <a:t>12. Conclusion et </a:t>
-            </a:r>
-            <a:r>
-              <a:rPr lang="fr-FR" sz="1800" b="1" dirty="0" smtClean="0">
-                <a:solidFill>
-                  <a:schemeClr val="tx1"/>
-                </a:solidFill>
-              </a:rPr>
-              <a:t>Perspectives</a:t>
-            </a:r>
-            <a:br>
-              <a:rPr lang="fr-FR" sz="1800" b="1" dirty="0" smtClean="0">
-                <a:solidFill>
-                  <a:schemeClr val="tx1"/>
-                </a:solidFill>
-              </a:rPr>
-            </a:br>
-            <a:endParaRPr lang="fr-FR" sz="1800" b="1" dirty="0">
+              <a:t>de la présentation</a:t>
+            </a:r>
+            <a:endParaRPr lang="fr-FR" dirty="0">
               <a:solidFill>
-                <a:schemeClr val="tx1"/>
+                <a:schemeClr val="accent3"/>
               </a:solidFill>
             </a:endParaRPr>
           </a:p>
@@ -7102,13 +7016,13 @@
             <a:spLocks noGrp="1"/>
           </p:cNvSpPr>
           <p:nvPr>
-            <p:ph type="subTitle" idx="1"/>
+            <p:ph idx="1"/>
           </p:nvPr>
         </p:nvSpPr>
         <p:spPr>
           <a:xfrm>
-            <a:off x="471340" y="5062194"/>
-            <a:ext cx="9509273" cy="840556"/>
+            <a:off x="2592371" y="1018095"/>
+            <a:ext cx="7457482" cy="5646657"/>
           </a:xfrm>
         </p:spPr>
         <p:txBody>
@@ -7117,23 +7031,124 @@
           </a:bodyPr>
           <a:lstStyle/>
           <a:p>
+            <a:pPr marL="0" indent="0">
+              <a:buNone/>
+            </a:pPr>
             <a:r>
               <a:rPr lang="fr-FR" sz="2800" b="1" dirty="0" smtClean="0">
                 <a:solidFill>
-                  <a:schemeClr val="tx1"/>
+                  <a:schemeClr val="accent3"/>
                 </a:solidFill>
               </a:rPr>
-              <a:t>Plan </a:t>
-            </a:r>
-            <a:r>
-              <a:rPr lang="fr-FR" sz="2800" b="1" dirty="0">
-                <a:solidFill>
-                  <a:schemeClr val="tx1"/>
-                </a:solidFill>
-              </a:rPr>
-              <a:t>de la présentation</a:t>
-            </a:r>
-            <a:endParaRPr lang="fr-FR" sz="2800" dirty="0"/>
+              <a:t>                    </a:t>
+            </a:r>
+            <a:r>
+              <a:rPr lang="fr-FR" b="1" dirty="0"/>
+              <a:t/>
+            </a:r>
+            <a:br>
+              <a:rPr lang="fr-FR" b="1" dirty="0"/>
+            </a:br>
+            <a:r>
+              <a:rPr lang="fr-FR" b="1" dirty="0" smtClean="0"/>
+              <a:t>1</a:t>
+            </a:r>
+            <a:r>
+              <a:rPr lang="fr-FR" b="1" dirty="0"/>
+              <a:t>. Introduction et Problématique</a:t>
+            </a:r>
+            <a:br>
+              <a:rPr lang="fr-FR" b="1" dirty="0"/>
+            </a:br>
+            <a:r>
+              <a:rPr lang="fr-FR" b="1" dirty="0"/>
+              <a:t>2. Objectifs du projet</a:t>
+            </a:r>
+            <a:br>
+              <a:rPr lang="fr-FR" b="1" dirty="0"/>
+            </a:br>
+            <a:r>
+              <a:rPr lang="fr-FR" b="1" dirty="0"/>
+              <a:t>3. Le Dataset (Pima Indians </a:t>
+            </a:r>
+            <a:r>
+              <a:rPr lang="fr-FR" b="1" dirty="0" err="1" smtClean="0"/>
+              <a:t>Diabetes</a:t>
+            </a:r>
+            <a:r>
+              <a:rPr lang="fr-FR" b="1" dirty="0" smtClean="0"/>
+              <a:t>)</a:t>
+            </a:r>
+            <a:r>
+              <a:rPr lang="fr-FR" b="1" dirty="0"/>
+              <a:t/>
+            </a:r>
+            <a:br>
+              <a:rPr lang="fr-FR" b="1" dirty="0"/>
+            </a:br>
+            <a:r>
+              <a:rPr lang="fr-FR" b="1" dirty="0"/>
+              <a:t>4. Analyse Exploratoire des Données</a:t>
+            </a:r>
+            <a:br>
+              <a:rPr lang="fr-FR" b="1" dirty="0"/>
+            </a:br>
+            <a:r>
+              <a:rPr lang="fr-FR" b="1" dirty="0"/>
+              <a:t>5. Préparation des Données</a:t>
+            </a:r>
+            <a:br>
+              <a:rPr lang="fr-FR" b="1" dirty="0"/>
+            </a:br>
+            <a:r>
+              <a:rPr lang="fr-FR" b="1" dirty="0"/>
+              <a:t>6. Modèles de Machine Learning utilisés</a:t>
+            </a:r>
+            <a:br>
+              <a:rPr lang="fr-FR" b="1" dirty="0"/>
+            </a:br>
+            <a:r>
+              <a:rPr lang="fr-FR" b="1" dirty="0"/>
+              <a:t>7. Évaluation et Comparaison</a:t>
+            </a:r>
+            <a:br>
+              <a:rPr lang="fr-FR" b="1" dirty="0"/>
+            </a:br>
+            <a:r>
+              <a:rPr lang="fr-FR" b="1" dirty="0"/>
+              <a:t>8. Déploiement de </a:t>
+            </a:r>
+            <a:r>
+              <a:rPr lang="fr-FR" b="1" dirty="0" smtClean="0"/>
+              <a:t>l'Application</a:t>
+            </a:r>
+            <a:r>
+              <a:rPr lang="fr-FR" b="1" dirty="0"/>
+              <a:t/>
+            </a:r>
+            <a:br>
+              <a:rPr lang="fr-FR" b="1" dirty="0"/>
+            </a:br>
+            <a:r>
+              <a:rPr lang="fr-FR" b="1" dirty="0"/>
+              <a:t>9</a:t>
+            </a:r>
+            <a:r>
+              <a:rPr lang="fr-FR" b="1" dirty="0" smtClean="0"/>
+              <a:t>. </a:t>
+            </a:r>
+            <a:r>
+              <a:rPr lang="fr-FR" b="1" dirty="0"/>
+              <a:t>Fonctionnalités</a:t>
+            </a:r>
+            <a:br>
+              <a:rPr lang="fr-FR" b="1" dirty="0"/>
+            </a:br>
+            <a:r>
+              <a:rPr lang="fr-FR" b="1" dirty="0" smtClean="0"/>
+              <a:t>10. Démonstration</a:t>
+            </a:r>
+            <a:endParaRPr lang="fr-FR" dirty="0"/>
           </a:p>
         </p:txBody>
       </p:sp>
@@ -7255,7 +7270,7 @@
             </a:r>
             <a:r>
               <a:rPr lang="fr-FR" b="1" dirty="0">
-                <a:latin typeface="Algerian" panose="04020705040A02060702" pitchFamily="82" charset="0"/>
+                <a:latin typeface="Arial Black" panose="020B0A04020102020204" pitchFamily="34" charset="0"/>
               </a:rPr>
               <a:t>Problème :</a:t>
             </a:r>
@@ -7312,13 +7327,13 @@
             </a:r>
             <a:r>
               <a:rPr lang="fr-FR" b="1" dirty="0" smtClean="0">
-                <a:latin typeface="Algerian" panose="04020705040A02060702" pitchFamily="82" charset="0"/>
+                <a:latin typeface="Arial Black" panose="020B0A04020102020204" pitchFamily="34" charset="0"/>
               </a:rPr>
               <a:t>Solution </a:t>
             </a:r>
             <a:r>
               <a:rPr lang="fr-FR" b="1" dirty="0">
-                <a:latin typeface="Algerian" panose="04020705040A02060702" pitchFamily="82" charset="0"/>
+                <a:latin typeface="Arial Black" panose="020B0A04020102020204" pitchFamily="34" charset="0"/>
               </a:rPr>
               <a:t>:</a:t>
             </a:r>
@@ -7606,23 +7621,7 @@
             </a:r>
             <a:r>
               <a:rPr lang="fr-FR" sz="1900" dirty="0"/>
-              <a:t>- XGBoost (</a:t>
-            </a:r>
-            <a:r>
-              <a:rPr lang="fr-FR" sz="1900" dirty="0" err="1"/>
-              <a:t>Extreme</a:t>
-            </a:r>
-            <a:r>
-              <a:rPr lang="fr-FR" sz="1900" dirty="0"/>
-              <a:t> Gradient </a:t>
-            </a:r>
-            <a:r>
-              <a:rPr lang="fr-FR" sz="1900" dirty="0" err="1"/>
-              <a:t>Boosting</a:t>
-            </a:r>
-            <a:r>
-              <a:rPr lang="fr-FR" sz="1900" dirty="0"/>
-              <a:t>)</a:t>
+              <a:t>- XGBoost (Extreme Gradient Boosting)</a:t>
             </a:r>
           </a:p>
           <a:p>
@@ -7635,15 +7634,7 @@
             </a:r>
             <a:r>
               <a:rPr lang="fr-FR" sz="1900" dirty="0"/>
-              <a:t>- LightGBM (Light Gradient </a:t>
-            </a:r>
-            <a:r>
-              <a:rPr lang="fr-FR" sz="1900" dirty="0" err="1"/>
-              <a:t>Boosting</a:t>
-            </a:r>
-            <a:r>
-              <a:rPr lang="fr-FR" sz="1900" dirty="0"/>
-              <a:t>)</a:t>
+              <a:t>- LightGBM (Light Gradient Boosting)</a:t>
             </a:r>
           </a:p>
           <a:p>
@@ -8093,7 +8084,6 @@
               <a:rPr lang="fr-FR" sz="4400" b="1" dirty="0"/>
               <a:t>Exploratoire des Données</a:t>
             </a:r>
-            <a:endParaRPr lang="fr-FR" sz="4400" b="1" dirty="0"/>
           </a:p>
         </p:txBody>
       </p:sp>
@@ -8733,23 +8723,7 @@
             </a:r>
             <a:r>
               <a:rPr lang="fr-FR" sz="3600" b="1" dirty="0"/>
-              <a:t>. XGBoost (</a:t>
-            </a:r>
-            <a:r>
-              <a:rPr lang="fr-FR" sz="3600" b="1" dirty="0" err="1"/>
-              <a:t>Extreme</a:t>
-            </a:r>
-            <a:r>
-              <a:rPr lang="fr-FR" sz="3600" b="1" dirty="0"/>
-              <a:t> Gradient </a:t>
-            </a:r>
-            <a:r>
-              <a:rPr lang="fr-FR" sz="3600" b="1" dirty="0" err="1"/>
-              <a:t>Boosting</a:t>
-            </a:r>
-            <a:r>
-              <a:rPr lang="fr-FR" sz="3600" b="1" dirty="0"/>
-              <a:t>)</a:t>
+              <a:t>. XGBoost (Extreme Gradient Boosting)</a:t>
             </a:r>
           </a:p>
           <a:p>
@@ -8758,13 +8732,8 @@
             </a:pPr>
             <a:r>
               <a:rPr lang="fr-FR" sz="2100" dirty="0"/>
-              <a:t>   - Algorithme de </a:t>
-            </a:r>
-            <a:r>
-              <a:rPr lang="fr-FR" sz="2100" dirty="0" err="1"/>
-              <a:t>boosting</a:t>
-            </a:r>
-            <a:endParaRPr lang="fr-FR" sz="2100" dirty="0"/>
+              <a:t>   - Algorithme de boosting</a:t>
+            </a:r>
           </a:p>
           <a:p>
             <a:pPr marL="0" indent="0">
@@ -8809,15 +8778,7 @@
             </a:pPr>
             <a:r>
               <a:rPr lang="fr-FR" sz="4000" b="1" dirty="0"/>
-              <a:t>3. LightGBM (Light Gradient </a:t>
-            </a:r>
-            <a:r>
-              <a:rPr lang="fr-FR" sz="4000" b="1" dirty="0" err="1"/>
-              <a:t>Boosting</a:t>
-            </a:r>
-            <a:r>
-              <a:rPr lang="fr-FR" sz="4000" b="1" dirty="0"/>
-              <a:t>)</a:t>
+              <a:t>3. LightGBM (Light Gradient Boosting)</a:t>
             </a:r>
           </a:p>
           <a:p>
@@ -8826,15 +8787,7 @@
             </a:pPr>
             <a:r>
               <a:rPr lang="fr-FR" sz="2100" dirty="0"/>
-              <a:t>   - </a:t>
-            </a:r>
-            <a:r>
-              <a:rPr lang="fr-FR" sz="2100" dirty="0" err="1"/>
-              <a:t>Boosting</a:t>
-            </a:r>
-            <a:r>
-              <a:rPr lang="fr-FR" sz="2100" dirty="0"/>
-              <a:t> optimisé pour la rapidité</a:t>
+              <a:t>   - Boosting optimisé pour la rapidité</a:t>
             </a:r>
           </a:p>
           <a:p>

</xml_diff>